<commit_message>
added a code block that removes duplicate plots in the passed rate of rise cuts directory and added the firs content to the honours meeting powerpoint
</commit_message>
<xml_diff>
--- a/honours_meetings/Honours_Meeting.pptx
+++ b/honours_meetings/Honours_Meeting.pptx
@@ -7,6 +7,10 @@
   <p:sldIdLst>
     <p:sldId id="256" r:id="rId2"/>
     <p:sldId id="257" r:id="rId3"/>
+    <p:sldId id="258" r:id="rId4"/>
+    <p:sldId id="259" r:id="rId5"/>
+    <p:sldId id="260" r:id="rId6"/>
+    <p:sldId id="261" r:id="rId7"/>
   </p:sldIdLst>
   <p:sldSz cx="12192000" cy="6858000"/>
   <p:notesSz cx="6858000" cy="9144000"/>
@@ -105,6 +109,11 @@
       </a:defRPr>
     </a:lvl9pPr>
   </p:defaultTextStyle>
+  <p:extLst>
+    <p:ext uri="{EFAFB233-063F-42B5-8137-9DF3F51BA10A}">
+      <p15:sldGuideLst xmlns:p15="http://schemas.microsoft.com/office/powerpoint/2012/main"/>
+    </p:ext>
+  </p:extLst>
 </p:presentation>
 </file>
 
@@ -257,7 +266,7 @@
           <a:p>
             <a:fld id="{8E236CBB-077A-4653-A878-12BD88E050C7}" type="datetimeFigureOut">
               <a:rPr lang="en-AU" smtClean="0"/>
-              <a:t>5/06/2026</a:t>
+              <a:t>16/07/2026</a:t>
             </a:fld>
             <a:endParaRPr lang="en-AU"/>
           </a:p>
@@ -457,7 +466,7 @@
           <a:p>
             <a:fld id="{8E236CBB-077A-4653-A878-12BD88E050C7}" type="datetimeFigureOut">
               <a:rPr lang="en-AU" smtClean="0"/>
-              <a:t>5/06/2026</a:t>
+              <a:t>16/07/2026</a:t>
             </a:fld>
             <a:endParaRPr lang="en-AU"/>
           </a:p>
@@ -667,7 +676,7 @@
           <a:p>
             <a:fld id="{8E236CBB-077A-4653-A878-12BD88E050C7}" type="datetimeFigureOut">
               <a:rPr lang="en-AU" smtClean="0"/>
-              <a:t>5/06/2026</a:t>
+              <a:t>16/07/2026</a:t>
             </a:fld>
             <a:endParaRPr lang="en-AU"/>
           </a:p>
@@ -867,7 +876,7 @@
           <a:p>
             <a:fld id="{8E236CBB-077A-4653-A878-12BD88E050C7}" type="datetimeFigureOut">
               <a:rPr lang="en-AU" smtClean="0"/>
-              <a:t>5/06/2026</a:t>
+              <a:t>16/07/2026</a:t>
             </a:fld>
             <a:endParaRPr lang="en-AU"/>
           </a:p>
@@ -1143,7 +1152,7 @@
           <a:p>
             <a:fld id="{8E236CBB-077A-4653-A878-12BD88E050C7}" type="datetimeFigureOut">
               <a:rPr lang="en-AU" smtClean="0"/>
-              <a:t>5/06/2026</a:t>
+              <a:t>16/07/2026</a:t>
             </a:fld>
             <a:endParaRPr lang="en-AU"/>
           </a:p>
@@ -1411,7 +1420,7 @@
           <a:p>
             <a:fld id="{8E236CBB-077A-4653-A878-12BD88E050C7}" type="datetimeFigureOut">
               <a:rPr lang="en-AU" smtClean="0"/>
-              <a:t>5/06/2026</a:t>
+              <a:t>16/07/2026</a:t>
             </a:fld>
             <a:endParaRPr lang="en-AU"/>
           </a:p>
@@ -1826,7 +1835,7 @@
           <a:p>
             <a:fld id="{8E236CBB-077A-4653-A878-12BD88E050C7}" type="datetimeFigureOut">
               <a:rPr lang="en-AU" smtClean="0"/>
-              <a:t>5/06/2026</a:t>
+              <a:t>16/07/2026</a:t>
             </a:fld>
             <a:endParaRPr lang="en-AU"/>
           </a:p>
@@ -1968,7 +1977,7 @@
           <a:p>
             <a:fld id="{8E236CBB-077A-4653-A878-12BD88E050C7}" type="datetimeFigureOut">
               <a:rPr lang="en-AU" smtClean="0"/>
-              <a:t>5/06/2026</a:t>
+              <a:t>16/07/2026</a:t>
             </a:fld>
             <a:endParaRPr lang="en-AU"/>
           </a:p>
@@ -2081,7 +2090,7 @@
           <a:p>
             <a:fld id="{8E236CBB-077A-4653-A878-12BD88E050C7}" type="datetimeFigureOut">
               <a:rPr lang="en-AU" smtClean="0"/>
-              <a:t>5/06/2026</a:t>
+              <a:t>16/07/2026</a:t>
             </a:fld>
             <a:endParaRPr lang="en-AU"/>
           </a:p>
@@ -2394,7 +2403,7 @@
           <a:p>
             <a:fld id="{8E236CBB-077A-4653-A878-12BD88E050C7}" type="datetimeFigureOut">
               <a:rPr lang="en-AU" smtClean="0"/>
-              <a:t>5/06/2026</a:t>
+              <a:t>16/07/2026</a:t>
             </a:fld>
             <a:endParaRPr lang="en-AU"/>
           </a:p>
@@ -2683,7 +2692,7 @@
           <a:p>
             <a:fld id="{8E236CBB-077A-4653-A878-12BD88E050C7}" type="datetimeFigureOut">
               <a:rPr lang="en-AU" smtClean="0"/>
-              <a:t>5/06/2026</a:t>
+              <a:t>16/07/2026</a:t>
             </a:fld>
             <a:endParaRPr lang="en-AU"/>
           </a:p>
@@ -2926,7 +2935,7 @@
           <a:p>
             <a:fld id="{8E236CBB-077A-4653-A878-12BD88E050C7}" type="datetimeFigureOut">
               <a:rPr lang="en-AU" smtClean="0"/>
-              <a:t>5/06/2026</a:t>
+              <a:t>16/07/2026</a:t>
             </a:fld>
             <a:endParaRPr lang="en-AU"/>
           </a:p>
@@ -3364,7 +3373,10 @@
           <a:bodyPr/>
           <a:lstStyle/>
           <a:p>
-            <a:endParaRPr lang="en-AU" dirty="0"/>
+            <a:r>
+              <a:rPr lang="en-AU" dirty="0"/>
+              <a:t>Slides for Honours Meeting</a:t>
+            </a:r>
           </a:p>
         </p:txBody>
       </p:sp>
@@ -3446,7 +3458,7 @@
           <a:p>
             <a:r>
               <a:rPr lang="en-AU" dirty="0"/>
-              <a:t>Notes						</a:t>
+              <a:t>16/07/2026 – meeting					</a:t>
             </a:r>
           </a:p>
         </p:txBody>
@@ -3469,17 +3481,142 @@
         </p:nvSpPr>
         <p:spPr/>
         <p:txBody>
-          <a:bodyPr/>
-          <a:lstStyle/>
-          <a:p>
+          <a:bodyPr>
+            <a:normAutofit fontScale="92500" lnSpcReduction="20000"/>
+          </a:bodyPr>
+          <a:lstStyle/>
+          <a:p>
+            <a:pPr>
+              <a:buFontTx/>
+              <a:buChar char="-"/>
+            </a:pPr>
             <a:r>
               <a:rPr lang="en-AU" dirty="0"/>
-              <a:t>Using data transfer service creates a directory with </a:t>
+              <a:t>Rate of rise filter</a:t>
+            </a:r>
+          </a:p>
+          <a:p>
+            <a:pPr lvl="1">
+              <a:buFontTx/>
+              <a:buChar char="-"/>
+            </a:pPr>
+            <a:r>
+              <a:rPr lang="en-AU" dirty="0"/>
+              <a:t>Used </a:t>
+            </a:r>
+            <a:r>
+              <a:rPr lang="en-AU" dirty="0" err="1"/>
+              <a:t>in_tns</a:t>
+            </a:r>
+            <a:r>
+              <a:rPr lang="en-AU" dirty="0"/>
+              <a:t> fink filter to find objects that had </a:t>
+            </a:r>
+            <a:r>
+              <a:rPr lang="en-AU" dirty="0" err="1"/>
+              <a:t>tns</a:t>
+            </a:r>
+            <a:r>
+              <a:rPr lang="en-AU" dirty="0"/>
+              <a:t> counterparts </a:t>
+            </a:r>
+          </a:p>
+          <a:p>
+            <a:pPr lvl="1">
+              <a:buFontTx/>
+              <a:buChar char="-"/>
+            </a:pPr>
+            <a:r>
+              <a:rPr lang="en-AU" dirty="0"/>
+              <a:t>Fink returned objects with </a:t>
+            </a:r>
+            <a:r>
+              <a:rPr lang="en-AU" dirty="0" err="1"/>
+              <a:t>tns</a:t>
+            </a:r>
+            <a:r>
+              <a:rPr lang="en-AU" dirty="0"/>
+              <a:t> names of SN before Rubin started</a:t>
+            </a:r>
+          </a:p>
+          <a:p>
+            <a:pPr lvl="1">
+              <a:buFontTx/>
+              <a:buChar char="-"/>
+            </a:pPr>
+            <a:r>
+              <a:rPr lang="en-AU" dirty="0"/>
+              <a:t>Resulted in 6 SN with at least an okay rise but strange declines.</a:t>
+            </a:r>
+          </a:p>
+          <a:p>
+            <a:pPr lvl="1">
+              <a:buFontTx/>
+              <a:buChar char="-"/>
+            </a:pPr>
+            <a:r>
+              <a:rPr lang="en-AU" dirty="0"/>
+              <a:t>Normalised the slopes of the fits by the peak brightness of each object, resulting in an average slope of 0.0053 and 0.0223 change in flux per day for the green and red band respectively.</a:t>
+            </a:r>
+          </a:p>
+          <a:p>
+            <a:pPr>
+              <a:buFontTx/>
+              <a:buChar char="-"/>
+            </a:pPr>
+            <a:r>
+              <a:rPr lang="en-AU" dirty="0"/>
+              <a:t>Ran the rate of rise filter against the 6 </a:t>
+            </a:r>
+            <a:r>
+              <a:rPr lang="en-AU" dirty="0" err="1"/>
+              <a:t>tns</a:t>
+            </a:r>
+            <a:r>
+              <a:rPr lang="en-AU" dirty="0"/>
+              <a:t> objects and 4 of them were recovered by the filter. </a:t>
+            </a:r>
+          </a:p>
+          <a:p>
+            <a:pPr>
+              <a:buFontTx/>
+              <a:buChar char="-"/>
+            </a:pPr>
+            <a:r>
+              <a:rPr lang="en-AU" dirty="0"/>
+              <a:t>Got a new computer. </a:t>
+            </a:r>
+          </a:p>
+          <a:p>
+            <a:pPr>
+              <a:buFontTx/>
+              <a:buChar char="-"/>
+            </a:pPr>
+            <a:r>
+              <a:rPr lang="en-AU" dirty="0"/>
+              <a:t>Getting timeout errors on the rate of rise filter now…</a:t>
+            </a:r>
+          </a:p>
+          <a:p>
+            <a:pPr marL="0" indent="0">
+              <a:buNone/>
+            </a:pPr>
+            <a:r>
+              <a:rPr lang="en-AU" dirty="0"/>
+              <a:t>- Want to get the current code bug free before moving onto to trying Bazin fits or a </a:t>
             </a:r>
             <a:r>
               <a:rPr lang="en-AU"/>
-              <a:t>the name </a:t>
-            </a:r>
+              <a:t>power law fit.</a:t>
+            </a:r>
+            <a:endParaRPr lang="en-AU" dirty="0"/>
+          </a:p>
+          <a:p>
+            <a:pPr>
+              <a:buFontTx/>
+              <a:buChar char="-"/>
+            </a:pPr>
+            <a:endParaRPr lang="en-AU" dirty="0"/>
           </a:p>
         </p:txBody>
       </p:sp>
@@ -3487,6 +3624,390 @@
     <p:extLst>
       <p:ext uri="{BB962C8B-B14F-4D97-AF65-F5344CB8AC3E}">
         <p14:creationId xmlns:p14="http://schemas.microsoft.com/office/powerpoint/2010/main" val="4031994702"/>
+      </p:ext>
+    </p:extLst>
+  </p:cSld>
+  <p:clrMapOvr>
+    <a:masterClrMapping/>
+  </p:clrMapOvr>
+</p:sld>
+</file>
+
+<file path=ppt/slides/slide3.xml><?xml version="1.0" encoding="utf-8"?>
+<p:sld xmlns:a="http://schemas.openxmlformats.org/drawingml/2006/main" xmlns:r="http://schemas.openxmlformats.org/officeDocument/2006/relationships" xmlns:p="http://schemas.openxmlformats.org/presentationml/2006/main">
+  <p:cSld>
+    <p:spTree>
+      <p:nvGrpSpPr>
+        <p:cNvPr id="1" name=""/>
+        <p:cNvGrpSpPr/>
+        <p:nvPr/>
+      </p:nvGrpSpPr>
+      <p:grpSpPr>
+        <a:xfrm>
+          <a:off x="0" y="0"/>
+          <a:ext cx="0" cy="0"/>
+          <a:chOff x="0" y="0"/>
+          <a:chExt cx="0" cy="0"/>
+        </a:xfrm>
+      </p:grpSpPr>
+      <p:sp>
+        <p:nvSpPr>
+          <p:cNvPr id="2" name="Title 1">
+            <a:extLst>
+              <a:ext uri="{FF2B5EF4-FFF2-40B4-BE49-F238E27FC236}">
+                <a16:creationId xmlns:a16="http://schemas.microsoft.com/office/drawing/2014/main" id="{88BF91AE-6B08-20EB-B080-E53CCC435136}"/>
+              </a:ext>
+            </a:extLst>
+          </p:cNvPr>
+          <p:cNvSpPr>
+            <a:spLocks noGrp="1"/>
+          </p:cNvSpPr>
+          <p:nvPr>
+            <p:ph type="title"/>
+          </p:nvPr>
+        </p:nvSpPr>
+        <p:spPr/>
+        <p:txBody>
+          <a:bodyPr/>
+          <a:lstStyle/>
+          <a:p>
+            <a:r>
+              <a:rPr lang="en-AU" dirty="0"/>
+              <a:t>Plots				</a:t>
+            </a:r>
+          </a:p>
+        </p:txBody>
+      </p:sp>
+      <p:pic>
+        <p:nvPicPr>
+          <p:cNvPr id="5" name="Content Placeholder 4">
+            <a:extLst>
+              <a:ext uri="{FF2B5EF4-FFF2-40B4-BE49-F238E27FC236}">
+                <a16:creationId xmlns:a16="http://schemas.microsoft.com/office/drawing/2014/main" id="{2E711E62-870F-376B-3B9F-8FB11439D686}"/>
+              </a:ext>
+            </a:extLst>
+          </p:cNvPr>
+          <p:cNvPicPr>
+            <a:picLocks noGrp="1" noChangeAspect="1"/>
+          </p:cNvPicPr>
+          <p:nvPr>
+            <p:ph idx="1"/>
+          </p:nvPr>
+        </p:nvPicPr>
+        <p:blipFill>
+          <a:blip r:embed="rId2">
+            <a:extLst>
+              <a:ext uri="{28A0092B-C50C-407E-A947-70E740481C1C}">
+                <a14:useLocalDpi xmlns:a14="http://schemas.microsoft.com/office/drawing/2010/main" val="0"/>
+              </a:ext>
+            </a:extLst>
+          </a:blip>
+          <a:stretch>
+            <a:fillRect/>
+          </a:stretch>
+        </p:blipFill>
+        <p:spPr>
+          <a:xfrm>
+            <a:off x="567933" y="1624457"/>
+            <a:ext cx="7252229" cy="4351338"/>
+          </a:xfrm>
+          <a:prstGeom prst="rect">
+            <a:avLst/>
+          </a:prstGeom>
+        </p:spPr>
+      </p:pic>
+    </p:spTree>
+    <p:extLst>
+      <p:ext uri="{BB962C8B-B14F-4D97-AF65-F5344CB8AC3E}">
+        <p14:creationId xmlns:p14="http://schemas.microsoft.com/office/powerpoint/2010/main" val="3872154902"/>
+      </p:ext>
+    </p:extLst>
+  </p:cSld>
+  <p:clrMapOvr>
+    <a:masterClrMapping/>
+  </p:clrMapOvr>
+</p:sld>
+</file>
+
+<file path=ppt/slides/slide4.xml><?xml version="1.0" encoding="utf-8"?>
+<p:sld xmlns:a="http://schemas.openxmlformats.org/drawingml/2006/main" xmlns:r="http://schemas.openxmlformats.org/officeDocument/2006/relationships" xmlns:p="http://schemas.openxmlformats.org/presentationml/2006/main">
+  <p:cSld>
+    <p:spTree>
+      <p:nvGrpSpPr>
+        <p:cNvPr id="1" name=""/>
+        <p:cNvGrpSpPr/>
+        <p:nvPr/>
+      </p:nvGrpSpPr>
+      <p:grpSpPr>
+        <a:xfrm>
+          <a:off x="0" y="0"/>
+          <a:ext cx="0" cy="0"/>
+          <a:chOff x="0" y="0"/>
+          <a:chExt cx="0" cy="0"/>
+        </a:xfrm>
+      </p:grpSpPr>
+      <p:sp>
+        <p:nvSpPr>
+          <p:cNvPr id="2" name="Title 1">
+            <a:extLst>
+              <a:ext uri="{FF2B5EF4-FFF2-40B4-BE49-F238E27FC236}">
+                <a16:creationId xmlns:a16="http://schemas.microsoft.com/office/drawing/2014/main" id="{9D59532E-0055-1BDC-F402-4F2D7C250D7F}"/>
+              </a:ext>
+            </a:extLst>
+          </p:cNvPr>
+          <p:cNvSpPr>
+            <a:spLocks noGrp="1"/>
+          </p:cNvSpPr>
+          <p:nvPr>
+            <p:ph type="title"/>
+          </p:nvPr>
+        </p:nvSpPr>
+        <p:spPr/>
+        <p:txBody>
+          <a:bodyPr/>
+          <a:lstStyle/>
+          <a:p>
+            <a:r>
+              <a:rPr lang="en-AU" dirty="0"/>
+              <a:t>plots</a:t>
+            </a:r>
+          </a:p>
+        </p:txBody>
+      </p:sp>
+      <p:pic>
+        <p:nvPicPr>
+          <p:cNvPr id="5" name="Content Placeholder 4">
+            <a:extLst>
+              <a:ext uri="{FF2B5EF4-FFF2-40B4-BE49-F238E27FC236}">
+                <a16:creationId xmlns:a16="http://schemas.microsoft.com/office/drawing/2014/main" id="{59CC6CBE-5781-8C2A-8315-C0C91C309343}"/>
+              </a:ext>
+            </a:extLst>
+          </p:cNvPr>
+          <p:cNvPicPr>
+            <a:picLocks noGrp="1" noChangeAspect="1"/>
+          </p:cNvPicPr>
+          <p:nvPr>
+            <p:ph idx="1"/>
+          </p:nvPr>
+        </p:nvPicPr>
+        <p:blipFill>
+          <a:blip r:embed="rId2">
+            <a:extLst>
+              <a:ext uri="{28A0092B-C50C-407E-A947-70E740481C1C}">
+                <a14:useLocalDpi xmlns:a14="http://schemas.microsoft.com/office/drawing/2010/main" val="0"/>
+              </a:ext>
+            </a:extLst>
+          </a:blip>
+          <a:stretch>
+            <a:fillRect/>
+          </a:stretch>
+        </p:blipFill>
+        <p:spPr>
+          <a:xfrm>
+            <a:off x="658368" y="1860794"/>
+            <a:ext cx="7252229" cy="4351338"/>
+          </a:xfrm>
+          <a:prstGeom prst="rect">
+            <a:avLst/>
+          </a:prstGeom>
+        </p:spPr>
+      </p:pic>
+    </p:spTree>
+    <p:extLst>
+      <p:ext uri="{BB962C8B-B14F-4D97-AF65-F5344CB8AC3E}">
+        <p14:creationId xmlns:p14="http://schemas.microsoft.com/office/powerpoint/2010/main" val="40446829"/>
+      </p:ext>
+    </p:extLst>
+  </p:cSld>
+  <p:clrMapOvr>
+    <a:masterClrMapping/>
+  </p:clrMapOvr>
+</p:sld>
+</file>
+
+<file path=ppt/slides/slide5.xml><?xml version="1.0" encoding="utf-8"?>
+<p:sld xmlns:a="http://schemas.openxmlformats.org/drawingml/2006/main" xmlns:r="http://schemas.openxmlformats.org/officeDocument/2006/relationships" xmlns:p="http://schemas.openxmlformats.org/presentationml/2006/main">
+  <p:cSld>
+    <p:spTree>
+      <p:nvGrpSpPr>
+        <p:cNvPr id="1" name=""/>
+        <p:cNvGrpSpPr/>
+        <p:nvPr/>
+      </p:nvGrpSpPr>
+      <p:grpSpPr>
+        <a:xfrm>
+          <a:off x="0" y="0"/>
+          <a:ext cx="0" cy="0"/>
+          <a:chOff x="0" y="0"/>
+          <a:chExt cx="0" cy="0"/>
+        </a:xfrm>
+      </p:grpSpPr>
+      <p:sp>
+        <p:nvSpPr>
+          <p:cNvPr id="2" name="Title 1">
+            <a:extLst>
+              <a:ext uri="{FF2B5EF4-FFF2-40B4-BE49-F238E27FC236}">
+                <a16:creationId xmlns:a16="http://schemas.microsoft.com/office/drawing/2014/main" id="{6C8A2134-5C1D-4175-7781-B738E9E34DCF}"/>
+              </a:ext>
+            </a:extLst>
+          </p:cNvPr>
+          <p:cNvSpPr>
+            <a:spLocks noGrp="1"/>
+          </p:cNvSpPr>
+          <p:nvPr>
+            <p:ph type="title"/>
+          </p:nvPr>
+        </p:nvSpPr>
+        <p:spPr/>
+        <p:txBody>
+          <a:bodyPr/>
+          <a:lstStyle/>
+          <a:p>
+            <a:r>
+              <a:rPr lang="en-AU" dirty="0"/>
+              <a:t>plots</a:t>
+            </a:r>
+          </a:p>
+        </p:txBody>
+      </p:sp>
+      <p:pic>
+        <p:nvPicPr>
+          <p:cNvPr id="5" name="Content Placeholder 4">
+            <a:extLst>
+              <a:ext uri="{FF2B5EF4-FFF2-40B4-BE49-F238E27FC236}">
+                <a16:creationId xmlns:a16="http://schemas.microsoft.com/office/drawing/2014/main" id="{EBACFF3E-1CDE-4E6B-988E-9379B350ED86}"/>
+              </a:ext>
+            </a:extLst>
+          </p:cNvPr>
+          <p:cNvPicPr>
+            <a:picLocks noGrp="1" noChangeAspect="1"/>
+          </p:cNvPicPr>
+          <p:nvPr>
+            <p:ph idx="1"/>
+          </p:nvPr>
+        </p:nvPicPr>
+        <p:blipFill>
+          <a:blip r:embed="rId2">
+            <a:extLst>
+              <a:ext uri="{28A0092B-C50C-407E-A947-70E740481C1C}">
+                <a14:useLocalDpi xmlns:a14="http://schemas.microsoft.com/office/drawing/2010/main" val="0"/>
+              </a:ext>
+            </a:extLst>
+          </a:blip>
+          <a:stretch>
+            <a:fillRect/>
+          </a:stretch>
+        </p:blipFill>
+        <p:spPr>
+          <a:xfrm>
+            <a:off x="1197462" y="1834568"/>
+            <a:ext cx="7252229" cy="4351338"/>
+          </a:xfrm>
+          <a:prstGeom prst="rect">
+            <a:avLst/>
+          </a:prstGeom>
+        </p:spPr>
+      </p:pic>
+    </p:spTree>
+    <p:extLst>
+      <p:ext uri="{BB962C8B-B14F-4D97-AF65-F5344CB8AC3E}">
+        <p14:creationId xmlns:p14="http://schemas.microsoft.com/office/powerpoint/2010/main" val="1003136821"/>
+      </p:ext>
+    </p:extLst>
+  </p:cSld>
+  <p:clrMapOvr>
+    <a:masterClrMapping/>
+  </p:clrMapOvr>
+</p:sld>
+</file>
+
+<file path=ppt/slides/slide6.xml><?xml version="1.0" encoding="utf-8"?>
+<p:sld xmlns:a="http://schemas.openxmlformats.org/drawingml/2006/main" xmlns:r="http://schemas.openxmlformats.org/officeDocument/2006/relationships" xmlns:p="http://schemas.openxmlformats.org/presentationml/2006/main">
+  <p:cSld>
+    <p:spTree>
+      <p:nvGrpSpPr>
+        <p:cNvPr id="1" name=""/>
+        <p:cNvGrpSpPr/>
+        <p:nvPr/>
+      </p:nvGrpSpPr>
+      <p:grpSpPr>
+        <a:xfrm>
+          <a:off x="0" y="0"/>
+          <a:ext cx="0" cy="0"/>
+          <a:chOff x="0" y="0"/>
+          <a:chExt cx="0" cy="0"/>
+        </a:xfrm>
+      </p:grpSpPr>
+      <p:sp>
+        <p:nvSpPr>
+          <p:cNvPr id="2" name="Title 1">
+            <a:extLst>
+              <a:ext uri="{FF2B5EF4-FFF2-40B4-BE49-F238E27FC236}">
+                <a16:creationId xmlns:a16="http://schemas.microsoft.com/office/drawing/2014/main" id="{6D485D16-A129-2182-E2C8-A8C47C316939}"/>
+              </a:ext>
+            </a:extLst>
+          </p:cNvPr>
+          <p:cNvSpPr>
+            <a:spLocks noGrp="1"/>
+          </p:cNvSpPr>
+          <p:nvPr>
+            <p:ph type="title"/>
+          </p:nvPr>
+        </p:nvSpPr>
+        <p:spPr/>
+        <p:txBody>
+          <a:bodyPr/>
+          <a:lstStyle/>
+          <a:p>
+            <a:r>
+              <a:rPr lang="en-AU" dirty="0"/>
+              <a:t>Plots	</a:t>
+            </a:r>
+          </a:p>
+        </p:txBody>
+      </p:sp>
+      <p:pic>
+        <p:nvPicPr>
+          <p:cNvPr id="5" name="Content Placeholder 4">
+            <a:extLst>
+              <a:ext uri="{FF2B5EF4-FFF2-40B4-BE49-F238E27FC236}">
+                <a16:creationId xmlns:a16="http://schemas.microsoft.com/office/drawing/2014/main" id="{C1A2CABA-AD69-3158-27B5-3B2A6C1214CE}"/>
+              </a:ext>
+            </a:extLst>
+          </p:cNvPr>
+          <p:cNvPicPr>
+            <a:picLocks noGrp="1" noChangeAspect="1"/>
+          </p:cNvPicPr>
+          <p:nvPr>
+            <p:ph idx="1"/>
+          </p:nvPr>
+        </p:nvPicPr>
+        <p:blipFill>
+          <a:blip r:embed="rId2">
+            <a:extLst>
+              <a:ext uri="{28A0092B-C50C-407E-A947-70E740481C1C}">
+                <a14:useLocalDpi xmlns:a14="http://schemas.microsoft.com/office/drawing/2010/main" val="0"/>
+              </a:ext>
+            </a:extLst>
+          </a:blip>
+          <a:stretch>
+            <a:fillRect/>
+          </a:stretch>
+        </p:blipFill>
+        <p:spPr>
+          <a:xfrm>
+            <a:off x="2469885" y="1825625"/>
+            <a:ext cx="7252229" cy="4351338"/>
+          </a:xfrm>
+          <a:prstGeom prst="rect">
+            <a:avLst/>
+          </a:prstGeom>
+        </p:spPr>
+      </p:pic>
+    </p:spTree>
+    <p:extLst>
+      <p:ext uri="{BB962C8B-B14F-4D97-AF65-F5344CB8AC3E}">
+        <p14:creationId xmlns:p14="http://schemas.microsoft.com/office/powerpoint/2010/main" val="117010438"/>
       </p:ext>
     </p:extLst>
   </p:cSld>

</xml_diff>